<commit_message>
Align role titles and experience with CV
Business Analyst titles replace founder titles, MyTicketSeller and NaijaFoodFestival are credited to HunterTV Africa, contract roles are marked, and experience is stated as nine years.
</commit_message>
<xml_diff>
--- a/01-delivered-case-studies/ecommerce-boss-event-automation/Deck/Executive_Deck.pptx
+++ b/01-delivered-case-studies/ecommerce-boss-event-automation/Deck/Executive_Deck.pptx
@@ -1680,7 +1680,7 @@
                 <a:ea typeface="Arial" pitchFamily="34" charset="-122"/>
                 <a:cs typeface="Arial" pitchFamily="34" charset="-120"/>
               </a:rPr>
-              <a:t>Founder and Lead Business Analyst</a:t>
+              <a:t>Business Analyst</a:t>
             </a:r>
             <a:endParaRPr lang="en-US" sz="1400" dirty="0"/>
           </a:p>
@@ -1893,6 +1893,10 @@
             <a:prstDash val="solid"/>
           </a:ln>
         </p:spPr>
+        <p:txBody>
+          <a:bodyPr/>
+          <a:p/>
+        </p:txBody>
       </p:sp>
       <p:sp>
         <p:nvSpPr>
@@ -2035,6 +2039,10 @@
             <a:prstDash val="solid"/>
           </a:ln>
         </p:spPr>
+        <p:txBody>
+          <a:bodyPr/>
+          <a:p/>
+        </p:txBody>
       </p:sp>
       <p:sp>
         <p:nvSpPr>
@@ -2138,6 +2146,10 @@
             <a:prstDash val="solid"/>
           </a:ln>
         </p:spPr>
+        <p:txBody>
+          <a:bodyPr/>
+          <a:p/>
+        </p:txBody>
       </p:sp>
       <p:sp>
         <p:nvSpPr>
@@ -2241,6 +2253,10 @@
             <a:prstDash val="solid"/>
           </a:ln>
         </p:spPr>
+        <p:txBody>
+          <a:bodyPr/>
+          <a:p/>
+        </p:txBody>
       </p:sp>
       <p:sp>
         <p:nvSpPr>
@@ -5914,6 +5930,10 @@
             <a:prstDash val="solid"/>
           </a:ln>
         </p:spPr>
+        <p:txBody>
+          <a:bodyPr/>
+          <a:p/>
+        </p:txBody>
       </p:sp>
       <p:sp>
         <p:nvSpPr>
@@ -6058,6 +6078,10 @@
             <a:prstDash val="solid"/>
           </a:ln>
         </p:spPr>
+        <p:txBody>
+          <a:bodyPr/>
+          <a:p/>
+        </p:txBody>
       </p:sp>
       <p:sp>
         <p:nvSpPr>
@@ -6202,6 +6226,10 @@
             <a:prstDash val="solid"/>
           </a:ln>
         </p:spPr>
+        <p:txBody>
+          <a:bodyPr/>
+          <a:p/>
+        </p:txBody>
       </p:sp>
       <p:sp>
         <p:nvSpPr>
@@ -6346,6 +6374,10 @@
             <a:prstDash val="solid"/>
           </a:ln>
         </p:spPr>
+        <p:txBody>
+          <a:bodyPr/>
+          <a:p/>
+        </p:txBody>
       </p:sp>
       <p:sp>
         <p:nvSpPr>

</xml_diff>